<commit_message>
prise en compte des reviews et des reference. Reste à integrer le nouveau table
</commit_message>
<xml_diff>
--- a/2026/PRESENTATION_SUJET_CANISIUS.pptx
+++ b/2026/PRESENTATION_SUJET_CANISIUS.pptx
@@ -234,7 +234,7 @@
           <a:p>
             <a:fld id="{D0A05C07-07F7-43C6-BEE1-85621C190CAF}" type="datetimeFigureOut">
               <a:rPr lang="fr-FR" smtClean="0"/>
-              <a:t>02/03/2026</a:t>
+              <a:t>19/03/2026</a:t>
             </a:fld>
             <a:endParaRPr lang="fr-FR"/>
           </a:p>
@@ -2378,7 +2378,7 @@
           <a:p>
             <a:fld id="{EC0EB49C-4A5C-4C42-86D2-CCF5C3360F0F}" type="datetimeFigureOut">
               <a:rPr lang="fr-FR" smtClean="0"/>
-              <a:t>02/03/2026</a:t>
+              <a:t>19/03/2026</a:t>
             </a:fld>
             <a:endParaRPr lang="fr-FR"/>
           </a:p>
@@ -2586,7 +2586,7 @@
           <a:p>
             <a:fld id="{EC0EB49C-4A5C-4C42-86D2-CCF5C3360F0F}" type="datetimeFigureOut">
               <a:rPr lang="fr-FR" smtClean="0"/>
-              <a:t>02/03/2026</a:t>
+              <a:t>19/03/2026</a:t>
             </a:fld>
             <a:endParaRPr lang="fr-FR"/>
           </a:p>
@@ -2842,7 +2842,7 @@
           <a:p>
             <a:fld id="{EC0EB49C-4A5C-4C42-86D2-CCF5C3360F0F}" type="datetimeFigureOut">
               <a:rPr lang="fr-FR" smtClean="0"/>
-              <a:t>02/03/2026</a:t>
+              <a:t>19/03/2026</a:t>
             </a:fld>
             <a:endParaRPr lang="fr-FR"/>
           </a:p>
@@ -3016,7 +3016,7 @@
           <a:p>
             <a:fld id="{EC0EB49C-4A5C-4C42-86D2-CCF5C3360F0F}" type="datetimeFigureOut">
               <a:rPr lang="fr-FR" smtClean="0"/>
-              <a:t>02/03/2026</a:t>
+              <a:t>19/03/2026</a:t>
             </a:fld>
             <a:endParaRPr lang="fr-FR"/>
           </a:p>
@@ -3359,7 +3359,7 @@
           <a:p>
             <a:fld id="{EC0EB49C-4A5C-4C42-86D2-CCF5C3360F0F}" type="datetimeFigureOut">
               <a:rPr lang="fr-FR" smtClean="0"/>
-              <a:t>02/03/2026</a:t>
+              <a:t>19/03/2026</a:t>
             </a:fld>
             <a:endParaRPr lang="fr-FR"/>
           </a:p>
@@ -3634,7 +3634,7 @@
           <a:p>
             <a:fld id="{EC0EB49C-4A5C-4C42-86D2-CCF5C3360F0F}" type="datetimeFigureOut">
               <a:rPr lang="fr-FR" smtClean="0"/>
-              <a:t>02/03/2026</a:t>
+              <a:t>19/03/2026</a:t>
             </a:fld>
             <a:endParaRPr lang="fr-FR"/>
           </a:p>
@@ -4013,7 +4013,7 @@
           <a:p>
             <a:fld id="{EC0EB49C-4A5C-4C42-86D2-CCF5C3360F0F}" type="datetimeFigureOut">
               <a:rPr lang="fr-FR" smtClean="0"/>
-              <a:t>02/03/2026</a:t>
+              <a:t>19/03/2026</a:t>
             </a:fld>
             <a:endParaRPr lang="fr-FR"/>
           </a:p>
@@ -4131,7 +4131,7 @@
           <a:p>
             <a:fld id="{EC0EB49C-4A5C-4C42-86D2-CCF5C3360F0F}" type="datetimeFigureOut">
               <a:rPr lang="fr-FR" smtClean="0"/>
-              <a:t>02/03/2026</a:t>
+              <a:t>19/03/2026</a:t>
             </a:fld>
             <a:endParaRPr lang="fr-FR"/>
           </a:p>
@@ -4302,7 +4302,7 @@
           <a:p>
             <a:fld id="{EC0EB49C-4A5C-4C42-86D2-CCF5C3360F0F}" type="datetimeFigureOut">
               <a:rPr lang="fr-FR" smtClean="0"/>
-              <a:t>02/03/2026</a:t>
+              <a:t>19/03/2026</a:t>
             </a:fld>
             <a:endParaRPr lang="fr-FR"/>
           </a:p>
@@ -4656,7 +4656,7 @@
           <a:p>
             <a:fld id="{EC0EB49C-4A5C-4C42-86D2-CCF5C3360F0F}" type="datetimeFigureOut">
               <a:rPr lang="fr-FR" smtClean="0"/>
-              <a:t>02/03/2026</a:t>
+              <a:t>19/03/2026</a:t>
             </a:fld>
             <a:endParaRPr lang="fr-FR"/>
           </a:p>
@@ -5038,7 +5038,7 @@
           <a:p>
             <a:fld id="{EC0EB49C-4A5C-4C42-86D2-CCF5C3360F0F}" type="datetimeFigureOut">
               <a:rPr lang="fr-FR" smtClean="0"/>
-              <a:t>02/03/2026</a:t>
+              <a:t>19/03/2026</a:t>
             </a:fld>
             <a:endParaRPr lang="fr-FR"/>
           </a:p>
@@ -5325,7 +5325,7 @@
           <a:p>
             <a:fld id="{EC0EB49C-4A5C-4C42-86D2-CCF5C3360F0F}" type="datetimeFigureOut">
               <a:rPr lang="fr-FR" smtClean="0"/>
-              <a:t>02/03/2026</a:t>
+              <a:t>19/03/2026</a:t>
             </a:fld>
             <a:endParaRPr lang="fr-FR"/>
           </a:p>
@@ -10003,7 +10003,7 @@
         <p:spPr/>
         <p:txBody>
           <a:bodyPr>
-            <a:normAutofit/>
+            <a:normAutofit fontScale="90000"/>
           </a:bodyPr>
           <a:lstStyle/>
           <a:p>
@@ -10013,7 +10013,7 @@
                   <a:schemeClr val="accent1"/>
                 </a:solidFill>
               </a:rPr>
-              <a:t>Plan</a:t>
+              <a:t>Plan de la présentation</a:t>
             </a:r>
             <a:r>
               <a:rPr lang="fr-FR" sz="7200" b="1" dirty="0">

</xml_diff>